<commit_message>
last commit before making major changes: Deleting files, reorganizing structure, and other stuff
</commit_message>
<xml_diff>
--- a/presentations_refernces/presentations/ゼミ_中嶋.pptx
+++ b/presentations_refernces/presentations/ゼミ_中嶋.pptx
@@ -221,7 +221,7 @@
           <a:p>
             <a:fld id="{C3F98DD7-F0CA-4392-97DB-FA1B6F34552E}" type="datetimeFigureOut">
               <a:rPr kumimoji="1" lang="ja-JP" altLang="en-US" smtClean="0"/>
-              <a:t>2024/8/1</a:t>
+              <a:t>2025/11/19</a:t>
             </a:fld>
             <a:endParaRPr kumimoji="1" lang="ja-JP" altLang="en-US"/>
           </a:p>
@@ -399,7 +399,7 @@
           <a:p>
             <a:fld id="{D067F8AC-0F6E-4BBB-9623-5DA9A58050FD}" type="datetimeFigureOut">
               <a:rPr kumimoji="1" lang="ja-JP" altLang="en-US" smtClean="0"/>
-              <a:t>2024/8/1</a:t>
+              <a:t>2025/11/19</a:t>
             </a:fld>
             <a:endParaRPr kumimoji="1" lang="ja-JP" altLang="en-US"/>
           </a:p>
@@ -2041,7 +2041,7 @@
           <a:p>
             <a:fld id="{C869CFA4-2189-45FE-974A-DE5524E735FA}" type="datetime1">
               <a:rPr kumimoji="1" lang="ja-JP" altLang="en-US" smtClean="0"/>
-              <a:t>2024/8/1</a:t>
+              <a:t>2025/11/19</a:t>
             </a:fld>
             <a:endParaRPr kumimoji="1" lang="ja-JP" altLang="en-US"/>
           </a:p>
@@ -2276,7 +2276,7 @@
           <a:p>
             <a:fld id="{648DE844-C191-49DB-B60B-B866EF67868B}" type="datetime1">
               <a:rPr kumimoji="1" lang="ja-JP" altLang="en-US" smtClean="0"/>
-              <a:t>2024/8/1</a:t>
+              <a:t>2025/11/19</a:t>
             </a:fld>
             <a:endParaRPr kumimoji="1" lang="ja-JP" altLang="en-US"/>
           </a:p>
@@ -2524,7 +2524,7 @@
           <a:p>
             <a:fld id="{8A859E7B-2023-4561-A649-623F8A6D6D12}" type="datetime1">
               <a:rPr kumimoji="1" lang="ja-JP" altLang="en-US" smtClean="0"/>
-              <a:t>2024/8/1</a:t>
+              <a:t>2025/11/19</a:t>
             </a:fld>
             <a:endParaRPr kumimoji="1" lang="ja-JP" altLang="en-US"/>
           </a:p>
@@ -2762,7 +2762,7 @@
           <a:p>
             <a:fld id="{3D01EB58-91B8-4450-9D81-227092B2F8A3}" type="datetime1">
               <a:rPr kumimoji="1" lang="ja-JP" altLang="en-US" smtClean="0"/>
-              <a:t>2024/8/1</a:t>
+              <a:t>2025/11/19</a:t>
             </a:fld>
             <a:endParaRPr kumimoji="1" lang="ja-JP" altLang="en-US"/>
           </a:p>
@@ -3045,7 +3045,7 @@
           <a:p>
             <a:fld id="{F9C7E83D-5322-4F0D-B25C-AE80B0F08974}" type="datetime1">
               <a:rPr kumimoji="1" lang="ja-JP" altLang="en-US" smtClean="0"/>
-              <a:t>2024/8/1</a:t>
+              <a:t>2025/11/19</a:t>
             </a:fld>
             <a:endParaRPr kumimoji="1" lang="ja-JP" altLang="en-US"/>
           </a:p>
@@ -3382,7 +3382,7 @@
           <a:p>
             <a:fld id="{296D8AFF-5F2D-45E1-8BA9-20A59AE89234}" type="datetime1">
               <a:rPr kumimoji="1" lang="ja-JP" altLang="en-US" smtClean="0"/>
-              <a:t>2024/8/1</a:t>
+              <a:t>2025/11/19</a:t>
             </a:fld>
             <a:endParaRPr kumimoji="1" lang="ja-JP" altLang="en-US"/>
           </a:p>
@@ -3866,7 +3866,7 @@
           <a:p>
             <a:fld id="{642C4D51-1CB4-45AF-BB76-26DAE2B3CD45}" type="datetime1">
               <a:rPr kumimoji="1" lang="ja-JP" altLang="en-US" smtClean="0"/>
-              <a:t>2024/8/1</a:t>
+              <a:t>2025/11/19</a:t>
             </a:fld>
             <a:endParaRPr kumimoji="1" lang="ja-JP" altLang="en-US"/>
           </a:p>
@@ -4015,7 +4015,7 @@
           <a:p>
             <a:fld id="{4EF1564C-A825-4F6C-938C-9AF5BAF1BDF9}" type="datetime1">
               <a:rPr kumimoji="1" lang="ja-JP" altLang="en-US" smtClean="0"/>
-              <a:t>2024/8/1</a:t>
+              <a:t>2025/11/19</a:t>
             </a:fld>
             <a:endParaRPr kumimoji="1" lang="ja-JP" altLang="en-US"/>
           </a:p>
@@ -4136,7 +4136,7 @@
           <a:p>
             <a:fld id="{027A3632-D32F-4240-B53B-BD2C894D7712}" type="datetime1">
               <a:rPr kumimoji="1" lang="ja-JP" altLang="en-US" smtClean="0"/>
-              <a:t>2024/8/1</a:t>
+              <a:t>2025/11/19</a:t>
             </a:fld>
             <a:endParaRPr kumimoji="1" lang="ja-JP" altLang="en-US"/>
           </a:p>
@@ -4487,7 +4487,7 @@
           <a:p>
             <a:fld id="{A54250A6-4486-493F-9AC0-84C8B0705AEC}" type="datetime1">
               <a:rPr kumimoji="1" lang="ja-JP" altLang="en-US" smtClean="0"/>
-              <a:t>2024/8/1</a:t>
+              <a:t>2025/11/19</a:t>
             </a:fld>
             <a:endParaRPr kumimoji="1" lang="ja-JP" altLang="en-US"/>
           </a:p>
@@ -4783,7 +4783,7 @@
           <a:p>
             <a:fld id="{652908AC-0D9E-489E-AE38-C0FD724FC7E7}" type="datetime1">
               <a:rPr kumimoji="1" lang="ja-JP" altLang="en-US" smtClean="0"/>
-              <a:t>2024/8/1</a:t>
+              <a:t>2025/11/19</a:t>
             </a:fld>
             <a:endParaRPr kumimoji="1" lang="ja-JP" altLang="en-US"/>
           </a:p>
@@ -5073,7 +5073,7 @@
           <a:p>
             <a:fld id="{DD0C3CFD-0487-4D55-88F3-2D5A2D3D792E}" type="datetime1">
               <a:rPr kumimoji="1" lang="ja-JP" altLang="en-US" smtClean="0"/>
-              <a:t>2024/8/1</a:t>
+              <a:t>2025/11/19</a:t>
             </a:fld>
             <a:endParaRPr kumimoji="1" lang="ja-JP" altLang="en-US"/>
           </a:p>

</xml_diff>